<commit_message>
document <S..S> serial pattern in usg + slides; bump to 3.0.16
</commit_message>
<xml_diff>
--- a/docs/slides/dsupdt_guide.pptx
+++ b/docs/slides/dsupdt_guide.pptx
@@ -17931,7 +17931,7 @@
                 <a:gridCol w="1371600"/>
                 <a:gridCol w="3749040"/>
               </a:tblGrid>
-              <a:tr h="402336">
+              <a:tr h="357632">
                 <a:tc>
                   <a:txBody>
                     <a:bodyPr/>
@@ -18137,7 +18137,7 @@
                   </a:tcPr>
                 </a:tc>
               </a:tr>
-              <a:tr h="402336">
+              <a:tr h="357632">
                 <a:tc>
                   <a:txBody>
                     <a:bodyPr/>
@@ -18343,7 +18343,7 @@
                   </a:tcPr>
                 </a:tc>
               </a:tr>
-              <a:tr h="402336">
+              <a:tr h="357632">
                 <a:tc>
                   <a:txBody>
                     <a:bodyPr/>
@@ -18549,7 +18549,7 @@
                   </a:tcPr>
                 </a:tc>
               </a:tr>
-              <a:tr h="402336">
+              <a:tr h="357632">
                 <a:tc>
                   <a:txBody>
                     <a:bodyPr/>
@@ -18755,7 +18755,7 @@
                   </a:tcPr>
                 </a:tc>
               </a:tr>
-              <a:tr h="402336">
+              <a:tr h="357632">
                 <a:tc>
                   <a:txBody>
                     <a:bodyPr/>
@@ -18961,7 +18961,7 @@
                   </a:tcPr>
                 </a:tc>
               </a:tr>
-              <a:tr h="402336">
+              <a:tr h="357632">
                 <a:tc>
                   <a:txBody>
                     <a:bodyPr/>
@@ -19167,7 +19167,7 @@
                   </a:tcPr>
                 </a:tc>
               </a:tr>
-              <a:tr h="402336">
+              <a:tr h="357632">
                 <a:tc>
                   <a:txBody>
                     <a:bodyPr/>
@@ -19373,7 +19373,7 @@
                   </a:tcPr>
                 </a:tc>
               </a:tr>
-              <a:tr h="402336">
+              <a:tr h="357632">
                 <a:tc>
                   <a:txBody>
                     <a:bodyPr/>
@@ -19575,6 +19575,212 @@
                     </a:lnB>
                     <a:solidFill>
                       <a:srgbClr val="FFFFFF"/>
+                    </a:solidFill>
+                  </a:tcPr>
+                </a:tc>
+              </a:tr>
+              <a:tr h="357632">
+                <a:tc>
+                  <a:txBody>
+                    <a:bodyPr/>
+                    <a:lstStyle/>
+                    <a:p>
+                      <a:pPr indent="0" marL="0">
+                        <a:buNone/>
+                      </a:pPr>
+                      <a:r>
+                        <a:rPr lang="en-US" sz="1250" b="1" dirty="0">
+                          <a:solidFill>
+                            <a:srgbClr val="0057C2"/>
+                          </a:solidFill>
+                          <a:latin typeface="Courier New" pitchFamily="34" charset="0"/>
+                          <a:ea typeface="Courier New" pitchFamily="34" charset="-122"/>
+                          <a:cs typeface="Courier New" pitchFamily="34" charset="-120"/>
+                        </a:rPr>
+                        <a:t>&lt;S01:03S&gt;</a:t>
+                      </a:r>
+                      <a:endParaRPr lang="en-US" sz="1250" dirty="0">
+                        <a:latin typeface="Courier New" charset="0"/>
+                        <a:ea typeface="Courier New" charset="0"/>
+                        <a:cs typeface="Courier New" charset="0"/>
+                      </a:endParaRPr>
+                    </a:p>
+                  </a:txBody>
+                  <a:tcPr marL="73152" marR="73152" marT="0" marB="0" anchor="ctr">
+                    <a:lnL w="6350" cap="flat" cmpd="sng" algn="ctr">
+                      <a:solidFill>
+                        <a:srgbClr val="A9D6F2"/>
+                      </a:solidFill>
+                      <a:prstDash val="solid"/>
+                      <a:round/>
+                      <a:headEnd type="none" w="med" len="med"/>
+                      <a:tailEnd type="none" w="med" len="med"/>
+                    </a:lnL>
+                    <a:lnR w="6350" cap="flat" cmpd="sng" algn="ctr">
+                      <a:solidFill>
+                        <a:srgbClr val="A9D6F2"/>
+                      </a:solidFill>
+                      <a:prstDash val="solid"/>
+                      <a:round/>
+                      <a:headEnd type="none" w="med" len="med"/>
+                      <a:tailEnd type="none" w="med" len="med"/>
+                    </a:lnR>
+                    <a:lnT w="6350" cap="flat" cmpd="sng" algn="ctr">
+                      <a:solidFill>
+                        <a:srgbClr val="A9D6F2"/>
+                      </a:solidFill>
+                      <a:prstDash val="solid"/>
+                      <a:round/>
+                      <a:headEnd type="none" w="med" len="med"/>
+                      <a:tailEnd type="none" w="med" len="med"/>
+                    </a:lnT>
+                    <a:lnB w="6350" cap="flat" cmpd="sng" algn="ctr">
+                      <a:solidFill>
+                        <a:srgbClr val="A9D6F2"/>
+                      </a:solidFill>
+                      <a:prstDash val="solid"/>
+                      <a:round/>
+                      <a:headEnd type="none" w="med" len="med"/>
+                      <a:tailEnd type="none" w="med" len="med"/>
+                    </a:lnB>
+                    <a:solidFill>
+                      <a:srgbClr val="DCEBF7"/>
+                    </a:solidFill>
+                  </a:tcPr>
+                </a:tc>
+                <a:tc>
+                  <a:txBody>
+                    <a:bodyPr/>
+                    <a:lstStyle/>
+                    <a:p>
+                      <a:pPr indent="0" marL="0">
+                        <a:buNone/>
+                      </a:pPr>
+                      <a:r>
+                        <a:rPr lang="en-US" sz="1250" b="1" dirty="0">
+                          <a:solidFill>
+                            <a:srgbClr val="0092DB"/>
+                          </a:solidFill>
+                          <a:latin typeface="Poppins" pitchFamily="34" charset="0"/>
+                          <a:ea typeface="Poppins" pitchFamily="34" charset="-122"/>
+                          <a:cs typeface="Poppins" pitchFamily="34" charset="-120"/>
+                        </a:rPr>
+                        <a:t>serial</a:t>
+                      </a:r>
+                      <a:endParaRPr lang="en-US" sz="1250" dirty="0">
+                        <a:latin typeface="Poppins" charset="0"/>
+                        <a:ea typeface="Poppins" charset="0"/>
+                        <a:cs typeface="Poppins" charset="0"/>
+                      </a:endParaRPr>
+                    </a:p>
+                  </a:txBody>
+                  <a:tcPr marL="73152" marR="73152" marT="0" marB="0" anchor="ctr">
+                    <a:lnL w="6350" cap="flat" cmpd="sng" algn="ctr">
+                      <a:solidFill>
+                        <a:srgbClr val="A9D6F2"/>
+                      </a:solidFill>
+                      <a:prstDash val="solid"/>
+                      <a:round/>
+                      <a:headEnd type="none" w="med" len="med"/>
+                      <a:tailEnd type="none" w="med" len="med"/>
+                    </a:lnL>
+                    <a:lnR w="6350" cap="flat" cmpd="sng" algn="ctr">
+                      <a:solidFill>
+                        <a:srgbClr val="A9D6F2"/>
+                      </a:solidFill>
+                      <a:prstDash val="solid"/>
+                      <a:round/>
+                      <a:headEnd type="none" w="med" len="med"/>
+                      <a:tailEnd type="none" w="med" len="med"/>
+                    </a:lnR>
+                    <a:lnT w="6350" cap="flat" cmpd="sng" algn="ctr">
+                      <a:solidFill>
+                        <a:srgbClr val="A9D6F2"/>
+                      </a:solidFill>
+                      <a:prstDash val="solid"/>
+                      <a:round/>
+                      <a:headEnd type="none" w="med" len="med"/>
+                      <a:tailEnd type="none" w="med" len="med"/>
+                    </a:lnT>
+                    <a:lnB w="6350" cap="flat" cmpd="sng" algn="ctr">
+                      <a:solidFill>
+                        <a:srgbClr val="A9D6F2"/>
+                      </a:solidFill>
+                      <a:prstDash val="solid"/>
+                      <a:round/>
+                      <a:headEnd type="none" w="med" len="med"/>
+                      <a:tailEnd type="none" w="med" len="med"/>
+                    </a:lnB>
+                    <a:solidFill>
+                      <a:srgbClr val="DCEBF7"/>
+                    </a:solidFill>
+                  </a:tcPr>
+                </a:tc>
+                <a:tc>
+                  <a:txBody>
+                    <a:bodyPr/>
+                    <a:lstStyle/>
+                    <a:p>
+                      <a:pPr indent="0" marL="0">
+                        <a:buNone/>
+                      </a:pPr>
+                      <a:r>
+                        <a:rPr lang="en-US" sz="1250" dirty="0">
+                          <a:solidFill>
+                            <a:srgbClr val="00357A"/>
+                          </a:solidFill>
+                          <a:latin typeface="Poppins" pitchFamily="34" charset="0"/>
+                          <a:ea typeface="Poppins" pitchFamily="34" charset="-122"/>
+                          <a:cs typeface="Poppins" pitchFamily="34" charset="-120"/>
+                        </a:rPr>
+                        <a:t>expand one name into 01,02,03 (padded to start width)</a:t>
+                      </a:r>
+                      <a:endParaRPr lang="en-US" sz="1250" dirty="0">
+                        <a:latin typeface="Poppins" charset="0"/>
+                        <a:ea typeface="Poppins" charset="0"/>
+                        <a:cs typeface="Poppins" charset="0"/>
+                      </a:endParaRPr>
+                    </a:p>
+                  </a:txBody>
+                  <a:tcPr marL="73152" marR="73152" marT="0" marB="0" anchor="ctr">
+                    <a:lnL w="6350" cap="flat" cmpd="sng" algn="ctr">
+                      <a:solidFill>
+                        <a:srgbClr val="A9D6F2"/>
+                      </a:solidFill>
+                      <a:prstDash val="solid"/>
+                      <a:round/>
+                      <a:headEnd type="none" w="med" len="med"/>
+                      <a:tailEnd type="none" w="med" len="med"/>
+                    </a:lnL>
+                    <a:lnR w="6350" cap="flat" cmpd="sng" algn="ctr">
+                      <a:solidFill>
+                        <a:srgbClr val="A9D6F2"/>
+                      </a:solidFill>
+                      <a:prstDash val="solid"/>
+                      <a:round/>
+                      <a:headEnd type="none" w="med" len="med"/>
+                      <a:tailEnd type="none" w="med" len="med"/>
+                    </a:lnR>
+                    <a:lnT w="6350" cap="flat" cmpd="sng" algn="ctr">
+                      <a:solidFill>
+                        <a:srgbClr val="A9D6F2"/>
+                      </a:solidFill>
+                      <a:prstDash val="solid"/>
+                      <a:round/>
+                      <a:headEnd type="none" w="med" len="med"/>
+                      <a:tailEnd type="none" w="med" len="med"/>
+                    </a:lnT>
+                    <a:lnB w="6350" cap="flat" cmpd="sng" algn="ctr">
+                      <a:solidFill>
+                        <a:srgbClr val="A9D6F2"/>
+                      </a:solidFill>
+                      <a:prstDash val="solid"/>
+                      <a:round/>
+                      <a:headEnd type="none" w="med" len="med"/>
+                      <a:tailEnd type="none" w="med" len="med"/>
+                    </a:lnB>
+                    <a:solidFill>
+                      <a:srgbClr val="DCEBF7"/>
                     </a:solidFill>
                   </a:tcPr>
                 </a:tc>

</xml_diff>